<commit_message>
Auto-build: 2026-04-08 10:31 UTC
</commit_message>
<xml_diff>
--- a/reports/2026-03.pptx
+++ b/reports/2026-03.pptx
@@ -238,19 +238,19 @@
                 <c:ptCount val="5"/>
                 <c:lvl>
                   <c:pt idx="0">
+                    <c:v>Tanzania</c:v>
+                  </c:pt>
+                  <c:pt idx="1">
                     <c:v>Kenya</c:v>
                   </c:pt>
-                  <c:pt idx="1">
+                  <c:pt idx="2">
                     <c:v>Uganda</c:v>
                   </c:pt>
-                  <c:pt idx="2">
+                  <c:pt idx="3">
                     <c:v>Sierra Leone</c:v>
                   </c:pt>
-                  <c:pt idx="3">
+                  <c:pt idx="4">
                     <c:v>Nigeria</c:v>
-                  </c:pt>
-                  <c:pt idx="4">
-                    <c:v>Tanzania</c:v>
                   </c:pt>
                 </c:lvl>
               </c:multiLvlStrCache>
@@ -263,19 +263,19 @@
                 <c:formatCode>General</c:formatCode>
                 <c:ptCount val="5"/>
                 <c:pt idx="0">
+                  <c:v>96</c:v>
+                </c:pt>
+                <c:pt idx="1">
                   <c:v>80</c:v>
                 </c:pt>
-                <c:pt idx="1">
+                <c:pt idx="2">
                   <c:v>74</c:v>
                 </c:pt>
-                <c:pt idx="2">
+                <c:pt idx="3">
                   <c:v>47</c:v>
                 </c:pt>
-                <c:pt idx="3">
+                <c:pt idx="4">
                   <c:v>37</c:v>
-                </c:pt>
-                <c:pt idx="4">
-                  <c:v>0</c:v>
                 </c:pt>
               </c:numCache>
             </c:numRef>
@@ -572,7 +572,7 @@
                   <c:v>40</c:v>
                 </c:pt>
                 <c:pt idx="3">
-                  <c:v>112</c:v>
+                  <c:v>64</c:v>
                 </c:pt>
                 <c:pt idx="4">
                   <c:v>113</c:v>
@@ -838,19 +838,19 @@
                 <c:ptCount val="5"/>
                 <c:lvl>
                   <c:pt idx="0">
+                    <c:v>Uganda</c:v>
+                  </c:pt>
+                  <c:pt idx="1">
                     <c:v>Kenya</c:v>
                   </c:pt>
-                  <c:pt idx="1">
+                  <c:pt idx="2">
                     <c:v>Nigeria</c:v>
                   </c:pt>
-                  <c:pt idx="2">
+                  <c:pt idx="3">
                     <c:v>Sierra Leone</c:v>
                   </c:pt>
-                  <c:pt idx="3">
+                  <c:pt idx="4">
                     <c:v>Tanzania</c:v>
-                  </c:pt>
-                  <c:pt idx="4">
-                    <c:v>Uganda</c:v>
                   </c:pt>
                 </c:lvl>
               </c:multiLvlStrCache>
@@ -863,16 +863,16 @@
                 <c:formatCode>General</c:formatCode>
                 <c:ptCount val="5"/>
                 <c:pt idx="0">
+                  <c:v>0.962191</c:v>
+                </c:pt>
+                <c:pt idx="1">
                   <c:v>0.94675</c:v>
                 </c:pt>
-                <c:pt idx="1">
+                <c:pt idx="2">
                   <c:v>0.915845</c:v>
                 </c:pt>
-                <c:pt idx="2">
+                <c:pt idx="3">
                   <c:v>0.882889</c:v>
-                </c:pt>
-                <c:pt idx="3">
-                  <c:v>0</c:v>
                 </c:pt>
                 <c:pt idx="4">
                   <c:v>0</c:v>
@@ -2038,19 +2038,19 @@
                 <c:ptCount val="5"/>
                 <c:lvl>
                   <c:pt idx="0">
+                    <c:v>Tanzania</c:v>
+                  </c:pt>
+                  <c:pt idx="1">
                     <c:v>Sierra Leone</c:v>
                   </c:pt>
-                  <c:pt idx="1">
+                  <c:pt idx="2">
                     <c:v>Kenya</c:v>
                   </c:pt>
-                  <c:pt idx="2">
+                  <c:pt idx="3">
                     <c:v>Uganda</c:v>
                   </c:pt>
-                  <c:pt idx="3">
+                  <c:pt idx="4">
                     <c:v>Nigeria</c:v>
-                  </c:pt>
-                  <c:pt idx="4">
-                    <c:v>Tanzania</c:v>
                   </c:pt>
                 </c:lvl>
               </c:multiLvlStrCache>
@@ -2066,7 +2066,7 @@
                   <c:v>3</c:v>
                 </c:pt>
                 <c:pt idx="1">
-                  <c:v>4</c:v>
+                  <c:v>3</c:v>
                 </c:pt>
                 <c:pt idx="2">
                   <c:v>4</c:v>
@@ -2075,7 +2075,7 @@
                   <c:v>4</c:v>
                 </c:pt>
                 <c:pt idx="4">
-                  <c:v>0</c:v>
+                  <c:v>4</c:v>
                 </c:pt>
               </c:numCache>
             </c:numRef>
@@ -2647,10 +2647,10 @@
                     <c:v>Uganda</c:v>
                   </c:pt>
                   <c:pt idx="3">
-                    <c:v>Kenya</c:v>
+                    <c:v>Tanzania</c:v>
                   </c:pt>
                   <c:pt idx="4">
-                    <c:v>Tanzania</c:v>
+                    <c:v>Kenya</c:v>
                   </c:pt>
                 </c:lvl>
               </c:multiLvlStrCache>
@@ -2672,10 +2672,10 @@
                   <c:v>1122</c:v>
                 </c:pt>
                 <c:pt idx="3">
-                  <c:v>1477</c:v>
+                  <c:v>1244</c:v>
                 </c:pt>
                 <c:pt idx="4">
-                  <c:v>2189</c:v>
+                  <c:v>1477</c:v>
                 </c:pt>
               </c:numCache>
             </c:numRef>
@@ -2975,7 +2975,7 @@
                   <c:v>193</c:v>
                 </c:pt>
                 <c:pt idx="4">
-                  <c:v>436</c:v>
+                  <c:v>248</c:v>
                 </c:pt>
               </c:numCache>
             </c:numRef>
@@ -8094,7 +8094,7 @@
                           <a:ea typeface="Calibri" pitchFamily="34" charset="-122"/>
                           <a:cs typeface="Calibri" pitchFamily="34" charset="-120"/>
                         </a:rPr>
-                        <a:t>$5,775</a:t>
+                        <a:t>$53,295</a:t>
                       </a:r>
                       <a:endParaRPr lang="en-US" sz="1200" dirty="0">
                         <a:latin typeface="Calibri" charset="0"/>
@@ -8162,7 +8162,7 @@
                           <a:ea typeface="Calibri" pitchFamily="34" charset="-122"/>
                           <a:cs typeface="Calibri" pitchFamily="34" charset="-120"/>
                         </a:rPr>
-                        <a:t>$-29,011</a:t>
+                        <a:t>$-33,474</a:t>
                       </a:r>
                       <a:endParaRPr lang="en-US" sz="1200" dirty="0">
                         <a:latin typeface="Calibri" charset="0"/>
@@ -8298,7 +8298,7 @@
                           <a:ea typeface="Calibri" pitchFamily="34" charset="-122"/>
                           <a:cs typeface="Calibri" pitchFamily="34" charset="-120"/>
                         </a:rPr>
-                        <a:t>$-71,897</a:t>
+                        <a:t>$-76,360</a:t>
                       </a:r>
                       <a:endParaRPr lang="en-US" sz="1200" dirty="0">
                         <a:latin typeface="Calibri" charset="0"/>
@@ -8366,7 +8366,7 @@
                           <a:ea typeface="Calibri" pitchFamily="34" charset="-122"/>
                           <a:cs typeface="Calibri" pitchFamily="34" charset="-120"/>
                         </a:rPr>
-                        <a:t>-1244.9%</a:t>
+                        <a:t>-143.3%</a:t>
                       </a:r>
                       <a:endParaRPr lang="en-US" sz="1200" dirty="0">
                         <a:latin typeface="Calibri" charset="0"/>
@@ -8572,7 +8572,7 @@
                           <a:ea typeface="Calibri" pitchFamily="34" charset="-122"/>
                           <a:cs typeface="Calibri" pitchFamily="34" charset="-120"/>
                         </a:rPr>
-                        <a:t>$2,089,484</a:t>
+                        <a:t>$2,137,004</a:t>
                       </a:r>
                       <a:endParaRPr lang="en-US" sz="1200" dirty="0">
                         <a:latin typeface="Calibri" charset="0"/>
@@ -8640,7 +8640,7 @@
                           <a:ea typeface="Calibri" pitchFamily="34" charset="-122"/>
                           <a:cs typeface="Calibri" pitchFamily="34" charset="-120"/>
                         </a:rPr>
-                        <a:t>$-350,732</a:t>
+                        <a:t>$-355,195</a:t>
                       </a:r>
                       <a:endParaRPr lang="en-US" sz="1200" dirty="0">
                         <a:latin typeface="Calibri" charset="0"/>
@@ -8776,7 +8776,7 @@
                           <a:ea typeface="Calibri" pitchFamily="34" charset="-122"/>
                           <a:cs typeface="Calibri" pitchFamily="34" charset="-120"/>
                         </a:rPr>
-                        <a:t>$430,802</a:t>
+                        <a:t>$426,339</a:t>
                       </a:r>
                       <a:endParaRPr lang="en-US" sz="1200" dirty="0">
                         <a:latin typeface="Calibri" charset="0"/>
@@ -8844,7 +8844,7 @@
                           <a:ea typeface="Calibri" pitchFamily="34" charset="-122"/>
                           <a:cs typeface="Calibri" pitchFamily="34" charset="-120"/>
                         </a:rPr>
-                        <a:t>20.6%</a:t>
+                        <a:t>20.0%</a:t>
                       </a:r>
                       <a:endParaRPr lang="en-US" sz="1200" dirty="0">
                         <a:latin typeface="Calibri" charset="0"/>
@@ -9097,7 +9097,7 @@
                 <a:ea typeface="Century Gothic" pitchFamily="34" charset="-122"/>
                 <a:cs typeface="Century Gothic" pitchFamily="34" charset="-120"/>
               </a:rPr>
-              <a:t>$2,089,484</a:t>
+              <a:t>$2,137,004</a:t>
             </a:r>
             <a:endParaRPr lang="en-US" sz="2600" dirty="0"/>
           </a:p>
@@ -9232,7 +9232,7 @@
                 <a:ea typeface="Century Gothic" pitchFamily="34" charset="-122"/>
                 <a:cs typeface="Century Gothic" pitchFamily="34" charset="-120"/>
               </a:rPr>
-              <a:t>$430,802</a:t>
+              <a:t>$426,339</a:t>
             </a:r>
             <a:endParaRPr lang="en-US" sz="2600" dirty="0"/>
           </a:p>
@@ -9367,7 +9367,7 @@
                 <a:ea typeface="Century Gothic" pitchFamily="34" charset="-122"/>
                 <a:cs typeface="Century Gothic" pitchFamily="34" charset="-120"/>
               </a:rPr>
-              <a:t>20.6%</a:t>
+              <a:t>20.0%</a:t>
             </a:r>
             <a:endParaRPr lang="en-US" sz="2600" dirty="0"/>
           </a:p>
@@ -9973,7 +9973,7 @@
                 <a:ea typeface="Calibri" pitchFamily="34" charset="-122"/>
                 <a:cs typeface="Calibri" pitchFamily="34" charset="-120"/>
               </a:rPr>
-              <a:t>-0.6%</a:t>
+              <a:t>-3.2%</a:t>
             </a:r>
             <a:endParaRPr lang="en-US" sz="1200" dirty="0"/>
           </a:p>
@@ -10012,7 +10012,7 @@
                 <a:ea typeface="Calibri" pitchFamily="34" charset="-122"/>
                 <a:cs typeface="Calibri" pitchFamily="34" charset="-120"/>
               </a:rPr>
-              <a:t>-3.2%</a:t>
+              <a:t>-0.6%</a:t>
             </a:r>
             <a:endParaRPr lang="en-US" sz="1200" dirty="0"/>
           </a:p>
@@ -10618,7 +10618,7 @@
                 <a:ea typeface="Calibri" pitchFamily="34" charset="-122"/>
                 <a:cs typeface="Calibri" pitchFamily="34" charset="-120"/>
               </a:rPr>
-              <a:t>+9.0%</a:t>
+              <a:t>+9.3%</a:t>
             </a:r>
             <a:endParaRPr lang="en-US" sz="1200" dirty="0"/>
           </a:p>
@@ -11469,7 +11469,7 @@
                 <a:ea typeface="Calibri" pitchFamily="34" charset="-122"/>
                 <a:cs typeface="Calibri" pitchFamily="34" charset="-120"/>
               </a:rPr>
-              <a:t>+47.4%</a:t>
+              <a:t>+48.8%</a:t>
             </a:r>
             <a:endParaRPr lang="en-US" sz="1200" dirty="0"/>
           </a:p>
@@ -12242,6 +12242,45 @@
                 <a:ea typeface="Calibri" pitchFamily="34" charset="-122"/>
                 <a:cs typeface="Calibri" pitchFamily="34" charset="-120"/>
               </a:rPr>
+              <a:t>-1.0%</a:t>
+            </a:r>
+            <a:endParaRPr lang="en-US" sz="1200" dirty="0"/>
+          </a:p>
+        </p:txBody>
+      </p:sp>
+      <p:sp>
+        <p:nvSpPr>
+          <p:cNvPr id="16" name="Text 13"/>
+          <p:cNvSpPr/>
+          <p:nvPr/>
+        </p:nvSpPr>
+        <p:spPr>
+          <a:xfrm>
+            <a:off x="1655064" y="5925312"/>
+            <a:ext cx="1517904" cy="347472"/>
+          </a:xfrm>
+          <a:prstGeom prst="rect">
+            <a:avLst/>
+          </a:prstGeom>
+          <a:noFill/>
+          <a:ln/>
+        </p:spPr>
+        <p:txBody>
+          <a:bodyPr wrap="square" rtlCol="0" anchor="ctr"/>
+          <a:lstStyle/>
+          <a:p>
+            <a:pPr algn="ctr" indent="0" marL="0">
+              <a:buNone/>
+            </a:pPr>
+            <a:r>
+              <a:rPr lang="en-US" sz="1200" b="1" dirty="0">
+                <a:solidFill>
+                  <a:srgbClr val="C0392B"/>
+                </a:solidFill>
+                <a:latin typeface="Calibri" pitchFamily="34" charset="0"/>
+                <a:ea typeface="Calibri" pitchFamily="34" charset="-122"/>
+                <a:cs typeface="Calibri" pitchFamily="34" charset="-120"/>
+              </a:rPr>
               <a:t>-5.9%</a:t>
             </a:r>
             <a:endParaRPr lang="en-US" sz="1200" dirty="0"/>
@@ -12250,13 +12289,13 @@
       </p:sp>
       <p:sp>
         <p:nvSpPr>
-          <p:cNvPr id="16" name="Text 13"/>
-          <p:cNvSpPr/>
-          <p:nvPr/>
-        </p:nvSpPr>
-        <p:spPr>
-          <a:xfrm>
-            <a:off x="1655064" y="5925312"/>
+          <p:cNvPr id="17" name="Text 14"/>
+          <p:cNvSpPr/>
+          <p:nvPr/>
+        </p:nvSpPr>
+        <p:spPr>
+          <a:xfrm>
+            <a:off x="3172968" y="5925312"/>
             <a:ext cx="1517904" cy="347472"/>
           </a:xfrm>
           <a:prstGeom prst="rect">
@@ -12289,13 +12328,13 @@
       </p:sp>
       <p:sp>
         <p:nvSpPr>
-          <p:cNvPr id="17" name="Text 14"/>
-          <p:cNvSpPr/>
-          <p:nvPr/>
-        </p:nvSpPr>
-        <p:spPr>
-          <a:xfrm>
-            <a:off x="3172968" y="5925312"/>
+          <p:cNvPr id="18" name="Text 15"/>
+          <p:cNvSpPr/>
+          <p:nvPr/>
+        </p:nvSpPr>
+        <p:spPr>
+          <a:xfrm>
+            <a:off x="4690872" y="5925312"/>
             <a:ext cx="1517904" cy="347472"/>
           </a:xfrm>
           <a:prstGeom prst="rect">
@@ -12328,13 +12367,13 @@
       </p:sp>
       <p:sp>
         <p:nvSpPr>
-          <p:cNvPr id="18" name="Text 15"/>
-          <p:cNvSpPr/>
-          <p:nvPr/>
-        </p:nvSpPr>
-        <p:spPr>
-          <a:xfrm>
-            <a:off x="4690872" y="5925312"/>
+          <p:cNvPr id="19" name="Text 16"/>
+          <p:cNvSpPr/>
+          <p:nvPr/>
+        </p:nvSpPr>
+        <p:spPr>
+          <a:xfrm>
+            <a:off x="6208776" y="5925312"/>
             <a:ext cx="1517904" cy="347472"/>
           </a:xfrm>
           <a:prstGeom prst="rect">
@@ -12360,45 +12399,6 @@
                 <a:cs typeface="Calibri" pitchFamily="34" charset="-120"/>
               </a:rPr>
               <a:t>-7.5%</a:t>
-            </a:r>
-            <a:endParaRPr lang="en-US" sz="1200" dirty="0"/>
-          </a:p>
-        </p:txBody>
-      </p:sp>
-      <p:sp>
-        <p:nvSpPr>
-          <p:cNvPr id="19" name="Text 16"/>
-          <p:cNvSpPr/>
-          <p:nvPr/>
-        </p:nvSpPr>
-        <p:spPr>
-          <a:xfrm>
-            <a:off x="6208776" y="5925312"/>
-            <a:ext cx="1517904" cy="347472"/>
-          </a:xfrm>
-          <a:prstGeom prst="rect">
-            <a:avLst/>
-          </a:prstGeom>
-          <a:noFill/>
-          <a:ln/>
-        </p:spPr>
-        <p:txBody>
-          <a:bodyPr wrap="square" rtlCol="0" anchor="ctr"/>
-          <a:lstStyle/>
-          <a:p>
-            <a:pPr algn="ctr" indent="0" marL="0">
-              <a:buNone/>
-            </a:pPr>
-            <a:r>
-              <a:rPr lang="en-US" sz="1200" b="1" dirty="0">
-                <a:solidFill>
-                  <a:srgbClr val="718096"/>
-                </a:solidFill>
-                <a:latin typeface="Calibri" pitchFamily="34" charset="0"/>
-                <a:ea typeface="Calibri" pitchFamily="34" charset="-122"/>
-                <a:cs typeface="Calibri" pitchFamily="34" charset="-120"/>
-              </a:rPr>
-              <a:t>-100.0%</a:t>
             </a:r>
             <a:endParaRPr lang="en-US" sz="1200" dirty="0"/>
           </a:p>
@@ -12494,7 +12494,7 @@
                 <a:ea typeface="Century Gothic" pitchFamily="34" charset="-122"/>
                 <a:cs typeface="Century Gothic" pitchFamily="34" charset="-120"/>
               </a:rPr>
-              <a:t>13,855</a:t>
+              <a:t>27,138</a:t>
             </a:r>
             <a:endParaRPr lang="en-US" sz="2600" dirty="0"/>
           </a:p>
@@ -12629,7 +12629,7 @@
                 <a:ea typeface="Century Gothic" pitchFamily="34" charset="-122"/>
                 <a:cs typeface="Century Gothic" pitchFamily="34" charset="-120"/>
               </a:rPr>
-              <a:t>48</a:t>
+              <a:t>78</a:t>
             </a:r>
             <a:endParaRPr lang="en-US" sz="2600" dirty="0"/>
           </a:p>
@@ -12764,7 +12764,7 @@
                 <a:ea typeface="Century Gothic" pitchFamily="34" charset="-122"/>
                 <a:cs typeface="Century Gothic" pitchFamily="34" charset="-120"/>
               </a:rPr>
-              <a:t>-40.7%</a:t>
+              <a:t>-3.7%</a:t>
             </a:r>
             <a:endParaRPr lang="en-US" sz="2600" dirty="0"/>
           </a:p>
@@ -12931,7 +12931,7 @@
                 <a:ea typeface="Calibri" pitchFamily="34" charset="-122"/>
                 <a:cs typeface="Calibri" pitchFamily="34" charset="-120"/>
               </a:rPr>
-              <a:t>Group total: 13,855 applications (-50.8% vs prior month).</a:t>
+              <a:t>Group total: 27,138 applications (-3.6% vs prior month).</a:t>
             </a:r>
             <a:endParaRPr lang="en-US" sz="1200" dirty="0"/>
           </a:p>
@@ -12948,7 +12948,7 @@
                 <a:ea typeface="Calibri" pitchFamily="34" charset="-122"/>
                 <a:cs typeface="Calibri" pitchFamily="34" charset="-120"/>
               </a:rPr>
-              <a:t>Kenya had the highest avg applications per team (80).</a:t>
+              <a:t>Tanzania had the highest avg applications per team (96).</a:t>
             </a:r>
             <a:endParaRPr lang="en-US" sz="1200" dirty="0"/>
           </a:p>
@@ -13392,13 +13392,13 @@
             <a:r>
               <a:rPr lang="en-US" sz="1200" b="1" dirty="0">
                 <a:solidFill>
-                  <a:srgbClr val="1A7A6E"/>
+                  <a:srgbClr val="C0392B"/>
                 </a:solidFill>
                 <a:latin typeface="Calibri" pitchFamily="34" charset="0"/>
                 <a:ea typeface="Calibri" pitchFamily="34" charset="-122"/>
                 <a:cs typeface="Calibri" pitchFamily="34" charset="-120"/>
               </a:rPr>
-              <a:t>↑</a:t>
+              <a:t>↓</a:t>
             </a:r>
             <a:endParaRPr lang="en-US" sz="1200" dirty="0"/>
           </a:p>
@@ -13509,13 +13509,13 @@
             <a:r>
               <a:rPr lang="en-US" sz="1200" b="1" dirty="0">
                 <a:solidFill>
-                  <a:srgbClr val="718096"/>
+                  <a:srgbClr val="1A7A6E"/>
                 </a:solidFill>
                 <a:latin typeface="Calibri" pitchFamily="34" charset="0"/>
                 <a:ea typeface="Calibri" pitchFamily="34" charset="-122"/>
                 <a:cs typeface="Calibri" pitchFamily="34" charset="-120"/>
               </a:rPr>
-              <a:t>—</a:t>
+              <a:t>↑</a:t>
             </a:r>
             <a:endParaRPr lang="en-US" sz="1200" dirty="0"/>
           </a:p>
@@ -13650,7 +13650,7 @@
                 <a:ea typeface="Century Gothic" pitchFamily="34" charset="-122"/>
                 <a:cs typeface="Century Gothic" pitchFamily="34" charset="-120"/>
               </a:rPr>
-              <a:t>10,299</a:t>
+              <a:t>13,022</a:t>
             </a:r>
             <a:endParaRPr lang="en-US" sz="2600" dirty="0"/>
           </a:p>
@@ -13785,7 +13785,7 @@
                 <a:ea typeface="Century Gothic" pitchFamily="34" charset="-122"/>
                 <a:cs typeface="Century Gothic" pitchFamily="34" charset="-120"/>
               </a:rPr>
-              <a:t>74.3%</a:t>
+              <a:t>48.0%</a:t>
             </a:r>
             <a:endParaRPr lang="en-US" sz="2600" dirty="0"/>
           </a:p>
@@ -14087,7 +14087,7 @@
                 <a:ea typeface="Calibri" pitchFamily="34" charset="-122"/>
                 <a:cs typeface="Calibri" pitchFamily="34" charset="-120"/>
               </a:rPr>
-              <a:t>Group total approvals: 10,299.</a:t>
+              <a:t>Group total approvals: 13,022.</a:t>
             </a:r>
             <a:endParaRPr lang="en-US" sz="1200" dirty="0"/>
           </a:p>
@@ -14104,7 +14104,7 @@
                 <a:ea typeface="Calibri" pitchFamily="34" charset="-122"/>
                 <a:cs typeface="Calibri" pitchFamily="34" charset="-120"/>
               </a:rPr>
-              <a:t>Kenya had the highest approval rate (94.7%).</a:t>
+              <a:t>Uganda had the highest approval rate (96.2%).</a:t>
             </a:r>
             <a:endParaRPr lang="en-US" sz="1200" dirty="0"/>
           </a:p>
@@ -15076,7 +15076,7 @@
                 <a:ea typeface="Century Gothic" pitchFamily="34" charset="-122"/>
                 <a:cs typeface="Century Gothic" pitchFamily="34" charset="-120"/>
               </a:rPr>
-              <a:t>89</a:t>
+              <a:t>74</a:t>
             </a:r>
             <a:endParaRPr lang="en-US" sz="2600" dirty="0"/>
           </a:p>
@@ -15307,7 +15307,7 @@
                 <a:ea typeface="Century Gothic" pitchFamily="34" charset="-122"/>
                 <a:cs typeface="Century Gothic" pitchFamily="34" charset="-120"/>
               </a:rPr>
-              <a:t>79</a:t>
+              <a:t>139</a:t>
             </a:r>
             <a:endParaRPr lang="en-US" sz="1100" dirty="0"/>
           </a:p>
@@ -17303,6 +17303,45 @@
             <a:r>
               <a:rPr lang="en-US" sz="1200" b="1" dirty="0">
                 <a:solidFill>
+                  <a:srgbClr val="C0392B"/>
+                </a:solidFill>
+                <a:latin typeface="Calibri" pitchFamily="34" charset="0"/>
+                <a:ea typeface="Calibri" pitchFamily="34" charset="-122"/>
+                <a:cs typeface="Calibri" pitchFamily="34" charset="-120"/>
+              </a:rPr>
+              <a:t>↑</a:t>
+            </a:r>
+            <a:endParaRPr lang="en-US" sz="1200" dirty="0"/>
+          </a:p>
+        </p:txBody>
+      </p:sp>
+      <p:sp>
+        <p:nvSpPr>
+          <p:cNvPr id="16" name="Text 13"/>
+          <p:cNvSpPr/>
+          <p:nvPr/>
+        </p:nvSpPr>
+        <p:spPr>
+          <a:xfrm>
+            <a:off x="1655064" y="5925312"/>
+            <a:ext cx="1517904" cy="347472"/>
+          </a:xfrm>
+          <a:prstGeom prst="rect">
+            <a:avLst/>
+          </a:prstGeom>
+          <a:noFill/>
+          <a:ln/>
+        </p:spPr>
+        <p:txBody>
+          <a:bodyPr wrap="square" rtlCol="0" anchor="ctr"/>
+          <a:lstStyle/>
+          <a:p>
+            <a:pPr algn="ctr" indent="0" marL="0">
+              <a:buNone/>
+            </a:pPr>
+            <a:r>
+              <a:rPr lang="en-US" sz="1200" b="1" dirty="0">
+                <a:solidFill>
                   <a:srgbClr val="1A7A6E"/>
                 </a:solidFill>
                 <a:latin typeface="Calibri" pitchFamily="34" charset="0"/>
@@ -17317,13 +17356,13 @@
       </p:sp>
       <p:sp>
         <p:nvSpPr>
-          <p:cNvPr id="16" name="Text 13"/>
-          <p:cNvSpPr/>
-          <p:nvPr/>
-        </p:nvSpPr>
-        <p:spPr>
-          <a:xfrm>
-            <a:off x="1655064" y="5925312"/>
+          <p:cNvPr id="17" name="Text 14"/>
+          <p:cNvSpPr/>
+          <p:nvPr/>
+        </p:nvSpPr>
+        <p:spPr>
+          <a:xfrm>
+            <a:off x="3172968" y="5925312"/>
             <a:ext cx="1517904" cy="347472"/>
           </a:xfrm>
           <a:prstGeom prst="rect">
@@ -17356,13 +17395,13 @@
       </p:sp>
       <p:sp>
         <p:nvSpPr>
-          <p:cNvPr id="17" name="Text 14"/>
-          <p:cNvSpPr/>
-          <p:nvPr/>
-        </p:nvSpPr>
-        <p:spPr>
-          <a:xfrm>
-            <a:off x="3172968" y="5925312"/>
+          <p:cNvPr id="18" name="Text 15"/>
+          <p:cNvSpPr/>
+          <p:nvPr/>
+        </p:nvSpPr>
+        <p:spPr>
+          <a:xfrm>
+            <a:off x="4690872" y="5925312"/>
             <a:ext cx="1517904" cy="347472"/>
           </a:xfrm>
           <a:prstGeom prst="rect">
@@ -17395,13 +17434,13 @@
       </p:sp>
       <p:sp>
         <p:nvSpPr>
-          <p:cNvPr id="18" name="Text 15"/>
-          <p:cNvSpPr/>
-          <p:nvPr/>
-        </p:nvSpPr>
-        <p:spPr>
-          <a:xfrm>
-            <a:off x="4690872" y="5925312"/>
+          <p:cNvPr id="19" name="Text 16"/>
+          <p:cNvSpPr/>
+          <p:nvPr/>
+        </p:nvSpPr>
+        <p:spPr>
+          <a:xfrm>
+            <a:off x="6208776" y="5925312"/>
             <a:ext cx="1517904" cy="347472"/>
           </a:xfrm>
           <a:prstGeom prst="rect">
@@ -17421,45 +17460,6 @@
               <a:rPr lang="en-US" sz="1200" b="1" dirty="0">
                 <a:solidFill>
                   <a:srgbClr val="1A7A6E"/>
-                </a:solidFill>
-                <a:latin typeface="Calibri" pitchFamily="34" charset="0"/>
-                <a:ea typeface="Calibri" pitchFamily="34" charset="-122"/>
-                <a:cs typeface="Calibri" pitchFamily="34" charset="-120"/>
-              </a:rPr>
-              <a:t>—</a:t>
-            </a:r>
-            <a:endParaRPr lang="en-US" sz="1200" dirty="0"/>
-          </a:p>
-        </p:txBody>
-      </p:sp>
-      <p:sp>
-        <p:nvSpPr>
-          <p:cNvPr id="19" name="Text 16"/>
-          <p:cNvSpPr/>
-          <p:nvPr/>
-        </p:nvSpPr>
-        <p:spPr>
-          <a:xfrm>
-            <a:off x="6208776" y="5925312"/>
-            <a:ext cx="1517904" cy="347472"/>
-          </a:xfrm>
-          <a:prstGeom prst="rect">
-            <a:avLst/>
-          </a:prstGeom>
-          <a:noFill/>
-          <a:ln/>
-        </p:spPr>
-        <p:txBody>
-          <a:bodyPr wrap="square" rtlCol="0" anchor="ctr"/>
-          <a:lstStyle/>
-          <a:p>
-            <a:pPr algn="ctr" indent="0" marL="0">
-              <a:buNone/>
-            </a:pPr>
-            <a:r>
-              <a:rPr lang="en-US" sz="1200" b="1" dirty="0">
-                <a:solidFill>
-                  <a:srgbClr val="718096"/>
                 </a:solidFill>
                 <a:latin typeface="Calibri" pitchFamily="34" charset="0"/>
                 <a:ea typeface="Calibri" pitchFamily="34" charset="-122"/>
@@ -17880,7 +17880,7 @@
                 <a:ea typeface="Calibri" pitchFamily="34" charset="-122"/>
                 <a:cs typeface="Calibri" pitchFamily="34" charset="-120"/>
               </a:rPr>
-              <a:t>Fastest: Sierra Leone (3 days). Slowest: Kenya (4 days).</a:t>
+              <a:t>Fastest: Tanzania (3 days). Slowest: Kenya (4 days).</a:t>
             </a:r>
             <a:endParaRPr lang="en-US" sz="1200" dirty="0"/>
           </a:p>

</xml_diff>

<commit_message>
Auto-build: 2026-04-08 12:44 UTC
</commit_message>
<xml_diff>
--- a/reports/2026-03.pptx
+++ b/reports/2026-03.pptx
@@ -8230,7 +8230,7 @@
                           <a:ea typeface="Calibri" pitchFamily="34" charset="-122"/>
                           <a:cs typeface="Calibri" pitchFamily="34" charset="-120"/>
                         </a:rPr>
-                        <a:t>$-85,204</a:t>
+                        <a:t>$-85,519</a:t>
                       </a:r>
                       <a:endParaRPr lang="en-US" sz="1200" dirty="0">
                         <a:latin typeface="Calibri" charset="0"/>
@@ -8298,7 +8298,7 @@
                           <a:ea typeface="Calibri" pitchFamily="34" charset="-122"/>
                           <a:cs typeface="Calibri" pitchFamily="34" charset="-120"/>
                         </a:rPr>
-                        <a:t>$-76,360</a:t>
+                        <a:t>$-65,698</a:t>
                       </a:r>
                       <a:endParaRPr lang="en-US" sz="1200" dirty="0">
                         <a:latin typeface="Calibri" charset="0"/>
@@ -8366,7 +8366,7 @@
                           <a:ea typeface="Calibri" pitchFamily="34" charset="-122"/>
                           <a:cs typeface="Calibri" pitchFamily="34" charset="-120"/>
                         </a:rPr>
-                        <a:t>-143.3%</a:t>
+                        <a:t>-123.3%</a:t>
                       </a:r>
                       <a:endParaRPr lang="en-US" sz="1200" dirty="0">
                         <a:latin typeface="Calibri" charset="0"/>
@@ -8708,7 +8708,7 @@
                           <a:ea typeface="Calibri" pitchFamily="34" charset="-122"/>
                           <a:cs typeface="Calibri" pitchFamily="34" charset="-120"/>
                         </a:rPr>
-                        <a:t>$-1,344,493</a:t>
+                        <a:t>$-1,344,808</a:t>
                       </a:r>
                       <a:endParaRPr lang="en-US" sz="1200" dirty="0">
                         <a:latin typeface="Calibri" charset="0"/>
@@ -8776,7 +8776,7 @@
                           <a:ea typeface="Calibri" pitchFamily="34" charset="-122"/>
                           <a:cs typeface="Calibri" pitchFamily="34" charset="-120"/>
                         </a:rPr>
-                        <a:t>$426,339</a:t>
+                        <a:t>$437,001</a:t>
                       </a:r>
                       <a:endParaRPr lang="en-US" sz="1200" dirty="0">
                         <a:latin typeface="Calibri" charset="0"/>
@@ -8844,7 +8844,7 @@
                           <a:ea typeface="Calibri" pitchFamily="34" charset="-122"/>
                           <a:cs typeface="Calibri" pitchFamily="34" charset="-120"/>
                         </a:rPr>
-                        <a:t>20.0%</a:t>
+                        <a:t>20.4%</a:t>
                       </a:r>
                       <a:endParaRPr lang="en-US" sz="1200" dirty="0">
                         <a:latin typeface="Calibri" charset="0"/>
@@ -9232,7 +9232,7 @@
                 <a:ea typeface="Century Gothic" pitchFamily="34" charset="-122"/>
                 <a:cs typeface="Century Gothic" pitchFamily="34" charset="-120"/>
               </a:rPr>
-              <a:t>$426,339</a:t>
+              <a:t>$437,001</a:t>
             </a:r>
             <a:endParaRPr lang="en-US" sz="2600" dirty="0"/>
           </a:p>
@@ -9367,7 +9367,7 @@
                 <a:ea typeface="Century Gothic" pitchFamily="34" charset="-122"/>
                 <a:cs typeface="Century Gothic" pitchFamily="34" charset="-120"/>
               </a:rPr>
-              <a:t>20.0%</a:t>
+              <a:t>20.4%</a:t>
             </a:r>
             <a:endParaRPr lang="en-US" sz="2600" dirty="0"/>
           </a:p>

</xml_diff>

<commit_message>
Auto-build: 2026-04-15 16:29 UTC
</commit_message>
<xml_diff>
--- a/reports/2026-03.pptx
+++ b/reports/2026-03.pptx
@@ -7138,7 +7138,7 @@
                           <a:ea typeface="Calibri" pitchFamily="34" charset="-122"/>
                           <a:cs typeface="Calibri" pitchFamily="34" charset="-120"/>
                         </a:rPr>
-                        <a:t>$217,691</a:t>
+                        <a:t>$220,744</a:t>
                       </a:r>
                       <a:endParaRPr lang="en-US" sz="1200" dirty="0">
                         <a:latin typeface="Calibri" charset="0"/>
@@ -7274,7 +7274,7 @@
                           <a:ea typeface="Calibri" pitchFamily="34" charset="-122"/>
                           <a:cs typeface="Calibri" pitchFamily="34" charset="-120"/>
                         </a:rPr>
-                        <a:t>$-182,780</a:t>
+                        <a:t>$-124,684</a:t>
                       </a:r>
                       <a:endParaRPr lang="en-US" sz="1200" dirty="0">
                         <a:latin typeface="Calibri" charset="0"/>
@@ -7342,7 +7342,7 @@
                           <a:ea typeface="Calibri" pitchFamily="34" charset="-122"/>
                           <a:cs typeface="Calibri" pitchFamily="34" charset="-120"/>
                         </a:rPr>
-                        <a:t>$29,590</a:t>
+                        <a:t>$90,739</a:t>
                       </a:r>
                       <a:endParaRPr lang="en-US" sz="1200" dirty="0">
                         <a:latin typeface="Calibri" charset="0"/>
@@ -7410,7 +7410,7 @@
                           <a:ea typeface="Calibri" pitchFamily="34" charset="-122"/>
                           <a:cs typeface="Calibri" pitchFamily="34" charset="-120"/>
                         </a:rPr>
-                        <a:t>13.6%</a:t>
+                        <a:t>41.1%</a:t>
                       </a:r>
                       <a:endParaRPr lang="en-US" sz="1200" dirty="0">
                         <a:latin typeface="Calibri" charset="0"/>
@@ -7478,7 +7478,7 @@
                           <a:ea typeface="Calibri" pitchFamily="34" charset="-122"/>
                           <a:cs typeface="Calibri" pitchFamily="34" charset="-120"/>
                         </a:rPr>
-                        <a:t>$66,026</a:t>
+                        <a:t>$68,359</a:t>
                       </a:r>
                       <a:endParaRPr lang="en-US" sz="1200" dirty="0">
                         <a:latin typeface="Calibri" charset="0"/>
@@ -8572,7 +8572,7 @@
                           <a:ea typeface="Calibri" pitchFamily="34" charset="-122"/>
                           <a:cs typeface="Calibri" pitchFamily="34" charset="-120"/>
                         </a:rPr>
-                        <a:t>$2,137,004</a:t>
+                        <a:t>$2,140,057</a:t>
                       </a:r>
                       <a:endParaRPr lang="en-US" sz="1200" dirty="0">
                         <a:latin typeface="Calibri" charset="0"/>
@@ -8708,7 +8708,7 @@
                           <a:ea typeface="Calibri" pitchFamily="34" charset="-122"/>
                           <a:cs typeface="Calibri" pitchFamily="34" charset="-120"/>
                         </a:rPr>
-                        <a:t>$-1,344,808</a:t>
+                        <a:t>$-1,286,713</a:t>
                       </a:r>
                       <a:endParaRPr lang="en-US" sz="1200" dirty="0">
                         <a:latin typeface="Calibri" charset="0"/>
@@ -8776,7 +8776,7 @@
                           <a:ea typeface="Calibri" pitchFamily="34" charset="-122"/>
                           <a:cs typeface="Calibri" pitchFamily="34" charset="-120"/>
                         </a:rPr>
-                        <a:t>$437,001</a:t>
+                        <a:t>$498,150</a:t>
                       </a:r>
                       <a:endParaRPr lang="en-US" sz="1200" dirty="0">
                         <a:latin typeface="Calibri" charset="0"/>
@@ -8844,7 +8844,7 @@
                           <a:ea typeface="Calibri" pitchFamily="34" charset="-122"/>
                           <a:cs typeface="Calibri" pitchFamily="34" charset="-120"/>
                         </a:rPr>
-                        <a:t>20.4%</a:t>
+                        <a:t>23.3%</a:t>
                       </a:r>
                       <a:endParaRPr lang="en-US" sz="1200" dirty="0">
                         <a:latin typeface="Calibri" charset="0"/>
@@ -8912,7 +8912,7 @@
                           <a:ea typeface="Calibri" pitchFamily="34" charset="-122"/>
                           <a:cs typeface="Calibri" pitchFamily="34" charset="-120"/>
                         </a:rPr>
-                        <a:t>$287,206</a:t>
+                        <a:t>$289,538</a:t>
                       </a:r>
                       <a:endParaRPr lang="en-US" sz="1200" dirty="0">
                         <a:latin typeface="Calibri" charset="0"/>
@@ -9097,7 +9097,7 @@
                 <a:ea typeface="Century Gothic" pitchFamily="34" charset="-122"/>
                 <a:cs typeface="Century Gothic" pitchFamily="34" charset="-120"/>
               </a:rPr>
-              <a:t>$2,137,004</a:t>
+              <a:t>$2,140,057</a:t>
             </a:r>
             <a:endParaRPr lang="en-US" sz="2600" dirty="0"/>
           </a:p>
@@ -9232,7 +9232,7 @@
                 <a:ea typeface="Century Gothic" pitchFamily="34" charset="-122"/>
                 <a:cs typeface="Century Gothic" pitchFamily="34" charset="-120"/>
               </a:rPr>
-              <a:t>$437,001</a:t>
+              <a:t>$498,150</a:t>
             </a:r>
             <a:endParaRPr lang="en-US" sz="2600" dirty="0"/>
           </a:p>
@@ -9367,7 +9367,7 @@
                 <a:ea typeface="Century Gothic" pitchFamily="34" charset="-122"/>
                 <a:cs typeface="Century Gothic" pitchFamily="34" charset="-120"/>
               </a:rPr>
-              <a:t>20.4%</a:t>
+              <a:t>23.3%</a:t>
             </a:r>
             <a:endParaRPr lang="en-US" sz="2600" dirty="0"/>
           </a:p>

</xml_diff>

<commit_message>
Auto-build: 2026-05-03 17:00 UTC
</commit_message>
<xml_diff>
--- a/reports/2026-03.pptx
+++ b/reports/2026-03.pptx
@@ -844,13 +844,13 @@
                     <c:v>Kenya</c:v>
                   </c:pt>
                   <c:pt idx="2">
+                    <c:v>Tanzania</c:v>
+                  </c:pt>
+                  <c:pt idx="3">
                     <c:v>Nigeria</c:v>
                   </c:pt>
-                  <c:pt idx="3">
+                  <c:pt idx="4">
                     <c:v>Sierra Leone</c:v>
-                  </c:pt>
-                  <c:pt idx="4">
-                    <c:v>Tanzania</c:v>
                   </c:pt>
                 </c:lvl>
               </c:multiLvlStrCache>
@@ -869,13 +869,13 @@
                   <c:v>0.94675</c:v>
                 </c:pt>
                 <c:pt idx="2">
+                  <c:v>0.946624</c:v>
+                </c:pt>
+                <c:pt idx="3">
                   <c:v>0.915845</c:v>
                 </c:pt>
-                <c:pt idx="3">
+                <c:pt idx="4">
                   <c:v>0.882889</c:v>
-                </c:pt>
-                <c:pt idx="4">
-                  <c:v>0</c:v>
                 </c:pt>
               </c:numCache>
             </c:numRef>
@@ -13548,13 +13548,13 @@
             <a:r>
               <a:rPr lang="en-US" sz="1200" b="1" dirty="0">
                 <a:solidFill>
-                  <a:srgbClr val="718096"/>
+                  <a:srgbClr val="1A7A6E"/>
                 </a:solidFill>
                 <a:latin typeface="Calibri" pitchFamily="34" charset="0"/>
                 <a:ea typeface="Calibri" pitchFamily="34" charset="-122"/>
                 <a:cs typeface="Calibri" pitchFamily="34" charset="-120"/>
               </a:rPr>
-              <a:t>—</a:t>
+              <a:t>↑</a:t>
             </a:r>
             <a:endParaRPr lang="en-US" sz="1200" dirty="0"/>
           </a:p>
@@ -13650,7 +13650,7 @@
                 <a:ea typeface="Century Gothic" pitchFamily="34" charset="-122"/>
                 <a:cs typeface="Century Gothic" pitchFamily="34" charset="-120"/>
               </a:rPr>
-              <a:t>13,022</a:t>
+              <a:t>25,596</a:t>
             </a:r>
             <a:endParaRPr lang="en-US" sz="2600" dirty="0"/>
           </a:p>
@@ -13785,7 +13785,7 @@
                 <a:ea typeface="Century Gothic" pitchFamily="34" charset="-122"/>
                 <a:cs typeface="Century Gothic" pitchFamily="34" charset="-120"/>
               </a:rPr>
-              <a:t>48.0%</a:t>
+              <a:t>94.3%</a:t>
             </a:r>
             <a:endParaRPr lang="en-US" sz="2600" dirty="0"/>
           </a:p>
@@ -13914,13 +13914,13 @@
             <a:r>
               <a:rPr lang="en-US" sz="2600" b="1" dirty="0">
                 <a:solidFill>
-                  <a:srgbClr val="C0392B"/>
+                  <a:srgbClr val="1A7A6E"/>
                 </a:solidFill>
                 <a:latin typeface="Century Gothic" pitchFamily="34" charset="0"/>
                 <a:ea typeface="Century Gothic" pitchFamily="34" charset="-122"/>
                 <a:cs typeface="Century Gothic" pitchFamily="34" charset="-120"/>
               </a:rPr>
-              <a:t>↓</a:t>
+              <a:t>↑</a:t>
             </a:r>
             <a:endParaRPr lang="en-US" sz="2600" dirty="0"/>
           </a:p>
@@ -14087,7 +14087,7 @@
                 <a:ea typeface="Calibri" pitchFamily="34" charset="-122"/>
                 <a:cs typeface="Calibri" pitchFamily="34" charset="-120"/>
               </a:rPr>
-              <a:t>Group total approvals: 13,022.</a:t>
+              <a:t>Group total approvals: 25,596.</a:t>
             </a:r>
             <a:endParaRPr lang="en-US" sz="1200" dirty="0"/>
           </a:p>

</xml_diff>